<commit_message>
Added DAC output pin label to schematic
</commit_message>
<xml_diff>
--- a/docs/CWtrainerSchematic.pptx
+++ b/docs/CWtrainerSchematic.pptx
@@ -259,7 +259,7 @@
           <a:p>
             <a:fld id="{3ABF883D-32AB-4847-8CB3-654CE255AAED}" type="datetimeFigureOut">
               <a:rPr lang="en-US" smtClean="0"/>
-              <a:t>7/3/2025</a:t>
+              <a:t>5/27/2026</a:t>
             </a:fld>
             <a:endParaRPr lang="en-US"/>
           </a:p>
@@ -457,7 +457,7 @@
           <a:p>
             <a:fld id="{3ABF883D-32AB-4847-8CB3-654CE255AAED}" type="datetimeFigureOut">
               <a:rPr lang="en-US" smtClean="0"/>
-              <a:t>7/3/2025</a:t>
+              <a:t>5/27/2026</a:t>
             </a:fld>
             <a:endParaRPr lang="en-US"/>
           </a:p>
@@ -665,7 +665,7 @@
           <a:p>
             <a:fld id="{3ABF883D-32AB-4847-8CB3-654CE255AAED}" type="datetimeFigureOut">
               <a:rPr lang="en-US" smtClean="0"/>
-              <a:t>7/3/2025</a:t>
+              <a:t>5/27/2026</a:t>
             </a:fld>
             <a:endParaRPr lang="en-US"/>
           </a:p>
@@ -863,7 +863,7 @@
           <a:p>
             <a:fld id="{3ABF883D-32AB-4847-8CB3-654CE255AAED}" type="datetimeFigureOut">
               <a:rPr lang="en-US" smtClean="0"/>
-              <a:t>7/3/2025</a:t>
+              <a:t>5/27/2026</a:t>
             </a:fld>
             <a:endParaRPr lang="en-US"/>
           </a:p>
@@ -1138,7 +1138,7 @@
           <a:p>
             <a:fld id="{3ABF883D-32AB-4847-8CB3-654CE255AAED}" type="datetimeFigureOut">
               <a:rPr lang="en-US" smtClean="0"/>
-              <a:t>7/3/2025</a:t>
+              <a:t>5/27/2026</a:t>
             </a:fld>
             <a:endParaRPr lang="en-US"/>
           </a:p>
@@ -1403,7 +1403,7 @@
           <a:p>
             <a:fld id="{3ABF883D-32AB-4847-8CB3-654CE255AAED}" type="datetimeFigureOut">
               <a:rPr lang="en-US" smtClean="0"/>
-              <a:t>7/3/2025</a:t>
+              <a:t>5/27/2026</a:t>
             </a:fld>
             <a:endParaRPr lang="en-US"/>
           </a:p>
@@ -1815,7 +1815,7 @@
           <a:p>
             <a:fld id="{3ABF883D-32AB-4847-8CB3-654CE255AAED}" type="datetimeFigureOut">
               <a:rPr lang="en-US" smtClean="0"/>
-              <a:t>7/3/2025</a:t>
+              <a:t>5/27/2026</a:t>
             </a:fld>
             <a:endParaRPr lang="en-US"/>
           </a:p>
@@ -1956,7 +1956,7 @@
           <a:p>
             <a:fld id="{3ABF883D-32AB-4847-8CB3-654CE255AAED}" type="datetimeFigureOut">
               <a:rPr lang="en-US" smtClean="0"/>
-              <a:t>7/3/2025</a:t>
+              <a:t>5/27/2026</a:t>
             </a:fld>
             <a:endParaRPr lang="en-US"/>
           </a:p>
@@ -2069,7 +2069,7 @@
           <a:p>
             <a:fld id="{3ABF883D-32AB-4847-8CB3-654CE255AAED}" type="datetimeFigureOut">
               <a:rPr lang="en-US" smtClean="0"/>
-              <a:t>7/3/2025</a:t>
+              <a:t>5/27/2026</a:t>
             </a:fld>
             <a:endParaRPr lang="en-US"/>
           </a:p>
@@ -2380,7 +2380,7 @@
           <a:p>
             <a:fld id="{3ABF883D-32AB-4847-8CB3-654CE255AAED}" type="datetimeFigureOut">
               <a:rPr lang="en-US" smtClean="0"/>
-              <a:t>7/3/2025</a:t>
+              <a:t>5/27/2026</a:t>
             </a:fld>
             <a:endParaRPr lang="en-US"/>
           </a:p>
@@ -2668,7 +2668,7 @@
           <a:p>
             <a:fld id="{3ABF883D-32AB-4847-8CB3-654CE255AAED}" type="datetimeFigureOut">
               <a:rPr lang="en-US" smtClean="0"/>
-              <a:t>7/3/2025</a:t>
+              <a:t>5/27/2026</a:t>
             </a:fld>
             <a:endParaRPr lang="en-US"/>
           </a:p>
@@ -2909,7 +2909,7 @@
           <a:p>
             <a:fld id="{3ABF883D-32AB-4847-8CB3-654CE255AAED}" type="datetimeFigureOut">
               <a:rPr lang="en-US" smtClean="0"/>
-              <a:t>7/3/2025</a:t>
+              <a:t>5/27/2026</a:t>
             </a:fld>
             <a:endParaRPr lang="en-US"/>
           </a:p>
@@ -7108,6 +7108,41 @@
           </a:p>
         </p:txBody>
       </p:sp>
+      <p:sp>
+        <p:nvSpPr>
+          <p:cNvPr id="11" name="TextBox 10">
+            <a:extLst>
+              <a:ext uri="{FF2B5EF4-FFF2-40B4-BE49-F238E27FC236}">
+                <a16:creationId xmlns:a16="http://schemas.microsoft.com/office/drawing/2014/main" id="{ADFF6B19-82BA-8F77-E2B3-E6A737F28AE4}"/>
+              </a:ext>
+            </a:extLst>
+          </p:cNvPr>
+          <p:cNvSpPr txBox="1"/>
+          <p:nvPr/>
+        </p:nvSpPr>
+        <p:spPr>
+          <a:xfrm>
+            <a:off x="6505230" y="2956976"/>
+            <a:ext cx="923651" cy="215444"/>
+          </a:xfrm>
+          <a:prstGeom prst="rect">
+            <a:avLst/>
+          </a:prstGeom>
+          <a:noFill/>
+        </p:spPr>
+        <p:txBody>
+          <a:bodyPr wrap="none" rtlCol="0">
+            <a:spAutoFit/>
+          </a:bodyPr>
+          <a:lstStyle/>
+          <a:p>
+            <a:r>
+              <a:rPr lang="en-US" sz="800" dirty="0"/>
+              <a:t>P014/DA0/AN009</a:t>
+            </a:r>
+          </a:p>
+        </p:txBody>
+      </p:sp>
     </p:spTree>
     <p:extLst>
       <p:ext uri="{BB962C8B-B14F-4D97-AF65-F5344CB8AC3E}">

</xml_diff>